<commit_message>
Finalize academic submission details and presentation
</commit_message>
<xml_diff>
--- a/presentation/MNIST_Presentation_Compatible.pptx
+++ b/presentation/MNIST_Presentation_Compatible.pptx
@@ -451,117 +451,21 @@
             <a:noAutofit/>
           </a:bodyPr>
           <a:p>
-            <a:pPr indent="0">
-              <a:lnSpc>
-                <a:spcPct val="100000"/>
-              </a:lnSpc>
-              <a:buNone/>
-            </a:pPr>
-            <a:r>
-              <a:rPr b="0" lang="en-US" sz="1200" strike="noStrike" u="none">
-                <a:solidFill>
-                  <a:srgbClr val="000000"/>
-                </a:solidFill>
-                <a:effectLst/>
-                <a:uFillTx/>
-                <a:latin typeface="Arial"/>
-              </a:rPr>
+            <a:r>
               <a:t>What to say. My project compares Scikit-learn Logistic Regression with a small TensorFlow/Keras neural network for handwritten digit recognition. I will explain the data preparation, the validation experiment, the final independent test results and the prediction demonstration.</a:t>
             </a:r>
-            <a:endParaRPr b="0" lang="en-US" sz="1200" strike="noStrike" u="none">
-              <a:solidFill>
-                <a:srgbClr val="000000"/>
-              </a:solidFill>
-              <a:effectLst/>
-              <a:uFillTx/>
-              <a:latin typeface="Arial"/>
-            </a:endParaRPr>
-          </a:p>
-          <a:p>
-            <a:pPr indent="0">
-              <a:lnSpc>
-                <a:spcPct val="100000"/>
-              </a:lnSpc>
-              <a:buNone/>
-            </a:pPr>
-            <a:endParaRPr b="0" lang="en-US" sz="1200" strike="noStrike" u="none">
-              <a:solidFill>
-                <a:srgbClr val="000000"/>
-              </a:solidFill>
-              <a:effectLst/>
-              <a:uFillTx/>
-              <a:latin typeface="Arial"/>
-            </a:endParaRPr>
-          </a:p>
-          <a:p>
-            <a:pPr indent="0">
-              <a:lnSpc>
-                <a:spcPct val="100000"/>
-              </a:lnSpc>
-              <a:buNone/>
-            </a:pPr>
-            <a:r>
-              <a:rPr b="0" lang="en-US" sz="1200" strike="noStrike" u="none">
-                <a:solidFill>
-                  <a:srgbClr val="000000"/>
-                </a:solidFill>
-                <a:effectLst/>
-                <a:uFillTx/>
-                <a:latin typeface="Arial"/>
-              </a:rPr>
-              <a:t>Before presenting. Replace [STUDENT NAME], [MATRICULATION NUMBER] and [INSTITUTION] on the cover. Add confirmed department, supervisor and submission date only if your institution requires them. Do not invent these details. The full official project title is the cover title.</a:t>
-            </a:r>
-            <a:endParaRPr b="0" lang="en-US" sz="1200" strike="noStrike" u="none">
-              <a:solidFill>
-                <a:srgbClr val="000000"/>
-              </a:solidFill>
-              <a:effectLst/>
-              <a:uFillTx/>
-              <a:latin typeface="Arial"/>
-            </a:endParaRPr>
-          </a:p>
-          <a:p>
-            <a:pPr indent="0">
-              <a:lnSpc>
-                <a:spcPct val="100000"/>
-              </a:lnSpc>
-              <a:buNone/>
-            </a:pPr>
-            <a:endParaRPr b="0" lang="en-US" sz="1200" strike="noStrike" u="none">
-              <a:solidFill>
-                <a:srgbClr val="000000"/>
-              </a:solidFill>
-              <a:effectLst/>
-              <a:uFillTx/>
-              <a:latin typeface="Arial"/>
-            </a:endParaRPr>
-          </a:p>
-          <a:p>
-            <a:pPr indent="0">
-              <a:lnSpc>
-                <a:spcPct val="100000"/>
-              </a:lnSpc>
-              <a:buNone/>
-            </a:pPr>
-            <a:r>
-              <a:rPr b="0" lang="en-US" sz="1200" strike="noStrike" u="none">
-                <a:solidFill>
-                  <a:srgbClr val="000000"/>
-                </a:solidFill>
-                <a:effectLst/>
-                <a:uFillTx/>
-                <a:latin typeface="Arial"/>
-              </a:rPr>
+          </a:p>
+          <a:p/>
+          <a:p>
+            <a:r>
+              <a:t>Presenter information. AJIBADE DARASIMI MICHAEL; matriculation number 2023/46544; Osun State University, Department of Computer Science. The supervisor and official submission date have not been confirmed and are therefore not attributed. The full official project title is the cover title.</a:t>
+            </a:r>
+          </a:p>
+          <a:p/>
+          <a:p>
+            <a:r>
               <a:t>Source. Original assignment PDF, pages 1 and 4. The technical report supplies the completed methodology and findings.</a:t>
             </a:r>
-            <a:endParaRPr b="0" lang="en-US" sz="1200" strike="noStrike" u="none">
-              <a:solidFill>
-                <a:srgbClr val="000000"/>
-              </a:solidFill>
-              <a:effectLst/>
-              <a:uFillTx/>
-              <a:latin typeface="Arial"/>
-            </a:endParaRPr>
           </a:p>
         </p:txBody>
       </p:sp>
@@ -4483,8 +4387,8 @@
         </p:nvSpPr>
         <p:spPr>
           <a:xfrm>
-            <a:off x="635040" y="5054760"/>
-            <a:ext cx="10794600" cy="1155240"/>
+            <a:off x="635040" y="4818888"/>
+            <a:ext cx="10794600" cy="1444752"/>
           </a:xfrm>
           <a:prstGeom prst="rect">
             <a:avLst/>
@@ -4509,6 +4413,12 @@
               <a:lnSpc>
                 <a:spcPts val="2341"/>
               </a:lnSpc>
+              <a:spcBef>
+                <a:spcPts val="0"/>
+              </a:spcBef>
+              <a:spcAft>
+                <a:spcPts val="400"/>
+              </a:spcAft>
             </a:pPr>
             <a:r>
               <a:rPr b="0" lang="en-US" sz="2000" strike="noStrike" u="none">
@@ -4520,7 +4430,7 @@
                 <a:latin typeface="Arial"/>
                 <a:ea typeface="Arial"/>
               </a:rPr>
-              <a:t>[STUDENT NAME]</a:t>
+              <a:t>AJIBADE DARASIMI MICHAEL</a:t>
             </a:r>
             <a:endParaRPr b="0" lang="en-US" sz="2000" strike="noStrike" u="none">
               <a:solidFill>
@@ -4536,6 +4446,12 @@
               <a:lnSpc>
                 <a:spcPts val="2341"/>
               </a:lnSpc>
+              <a:spcBef>
+                <a:spcPts val="0"/>
+              </a:spcBef>
+              <a:spcAft>
+                <a:spcPts val="400"/>
+              </a:spcAft>
             </a:pPr>
             <a:r>
               <a:rPr b="0" lang="en-US" sz="2000" strike="noStrike" u="none">
@@ -4547,7 +4463,7 @@
                 <a:latin typeface="Arial"/>
                 <a:ea typeface="Arial"/>
               </a:rPr>
-              <a:t>[MATRICULATION NUMBER]</a:t>
+              <a:t>MATRIC NO.: 2023/46544</a:t>
             </a:r>
             <a:endParaRPr b="0" lang="en-US" sz="2000" strike="noStrike" u="none">
               <a:solidFill>
@@ -4563,6 +4479,12 @@
               <a:lnSpc>
                 <a:spcPts val="2341"/>
               </a:lnSpc>
+              <a:spcBef>
+                <a:spcPts val="0"/>
+              </a:spcBef>
+              <a:spcAft>
+                <a:spcPts val="400"/>
+              </a:spcAft>
             </a:pPr>
             <a:r>
               <a:rPr b="0" lang="en-US" sz="2000" strike="noStrike" u="none">
@@ -4574,7 +4496,7 @@
                 <a:latin typeface="Arial"/>
                 <a:ea typeface="Arial"/>
               </a:rPr>
-              <a:t>[INSTITUTION]</a:t>
+              <a:t>OSUN STATE UNIVERSITY</a:t>
             </a:r>
             <a:endParaRPr b="0" lang="en-US" sz="2000" strike="noStrike" u="none">
               <a:solidFill>
@@ -4584,6 +4506,20 @@
               <a:uFillTx/>
               <a:latin typeface="Arial"/>
             </a:endParaRPr>
+          </a:p>
+          <a:p>
+            <a:pPr>
+              <a:spcBef>
+                <a:spcPts val="0"/>
+              </a:spcBef>
+              <a:spcAft>
+                <a:spcPts val="400"/>
+              </a:spcAft>
+              <a:defRPr sz="2000" b="0"/>
+            </a:pPr>
+            <a:r>
+              <a:t>DEPARTMENT OF COMPUTER SCIENCE</a:t>
+            </a:r>
           </a:p>
         </p:txBody>
       </p:sp>

</xml_diff>